<commit_message>
deck: slide 10 says $0 — emphasize zero incremental cost
Old slide 10 showed '~6 cents per run / Free transcription tier / Zero
per-developer license'. The 6-cents number was inherited from an older
deck snapshot when Nucleus was billed against the per-token Claude API.

Today the system runs on Claude Max-tier auth (bind-mounted
~/.claude/.credentials.json on .123), Groq free tier for transcription,
and the existing OpenProject Linux host -- so the marginal cost per
run is effectively $0.

New slide 10:
  - Hero: massive '$0' at 200pt navy
  - Headline: 'No per-run charge. No per-developer license. No new
    infrastructure cost.'
  - 2x2 supporting strip: AI / transcription / central server / runner+storage,
    each annotated with why it costs nothing (existing subscription,
    free tier, shared host, self-hosted).

Speaker notes call out the Max-tier mechanics, the prior 6-cents
disclaimer, and the components paid for once vs free-tier.
</commit_message>
<xml_diff>
--- a/docs/NAPCO-Nucleus-System-Overview.pptx
+++ b/docs/NAPCO-Nucleus-System-Overview.pptx
@@ -583,7 +583,7 @@
           <a:lstStyle/>
           <a:p>
             <a:r>
-              <a:t>Cost story for the budget conversation. The ~6 cents per run figure is the Anthropic Claude cost for a single daily verify_session pass on a ~16k character Pull Session document, with prompt caching enabled. The 'free' transcription tier is Groq's free quota of 8 hours of audio per day -- comfortably covers our actual call volume. 'Zero per-developer license' is because the AI access uses an Anthropic Max-tier subscription mounted into the worker containers, not per-seat keys. Infrastructure costs are the existing Linux host (already paid for, shared with OpenProject) and the developers' existing PCs. Nothing new to buy.</a:t>
+              <a:t>Cost story for the budget conversation. The incremental cost of running Nucleus per daily pass is effectively zero -- there is no new line item on anyone's bill. The AI side runs against an Anthropic Claude Max-tier subscription, which is a flat monthly subscription we already have in place; it's not metered per token, so the daily verify_session pass doesn't show up as a per-run charge. Audio transcription goes through Groq's free tier -- 8 hours of audio per day, which is well above our actual call volume. The central server is 172.16.205.123, the Linux box that already hosts our OpenProject instance; Nucleus runs as a docker-compose stack alongside it on the same host, so there is no new VM, no new cloud subscription, no new hardware. The GitHub Actions runner that builds and deploys the stack is self-hosted on the same .123 box, so we don't pay GitHub for runner minutes or artifact storage. Heads up on an older number that may surface: a prior version of this deck quoted '~6 cents per run' as the Claude cost. That figure came from a snapshot where Nucleus was billed against the regular Claude API with per-token pricing. Since we moved to Max-tier subscription auth, that per-run charge no longer applies -- the subscription is flat and the marginal cost of one more daily run is $0.</a:t>
             </a:r>
           </a:p>
         </p:txBody>
@@ -4540,7 +4540,7 @@
                 </a:solidFill>
                 <a:latin typeface="Calibri"/>
               </a:rPr>
-              <a:t>What it costs us</a:t>
+              <a:t>What it costs</a:t>
             </a:r>
           </a:p>
           <a:p>
@@ -4556,7 +4556,7 @@
                 </a:solidFill>
                 <a:latin typeface="Calibri"/>
               </a:rPr>
-              <a:t>Cheap to run. No per-seat license.</a:t>
+              <a:t>No new line items. No per-run charge.</a:t>
             </a:r>
           </a:p>
         </p:txBody>
@@ -4606,20 +4606,90 @@
       </p:sp>
       <p:sp>
         <p:nvSpPr>
-          <p:cNvPr id="5" name="Rectangle 4"/>
+          <p:cNvPr id="5" name="TextBox 4"/>
+          <p:cNvSpPr txBox="1"/>
+          <p:nvPr/>
+        </p:nvSpPr>
+        <p:spPr>
+          <a:xfrm>
+            <a:off x="640080" y="1371600"/>
+            <a:ext cx="10881360" cy="2377440"/>
+          </a:xfrm>
+          <a:prstGeom prst="rect">
+            <a:avLst/>
+          </a:prstGeom>
+          <a:noFill/>
+        </p:spPr>
+        <p:txBody>
+          <a:bodyPr wrap="square" lIns="0" rIns="0" tIns="0" bIns="0" anchor="ctr">
+            <a:spAutoFit/>
+          </a:bodyPr>
+          <a:lstStyle/>
+          <a:p>
+            <a:pPr algn="ctr"/>
+            <a:r>
+              <a:rPr sz="20000" b="1">
+                <a:solidFill>
+                  <a:srgbClr val="1F4E79"/>
+                </a:solidFill>
+                <a:latin typeface="Calibri"/>
+              </a:rPr>
+              <a:t>$0</a:t>
+            </a:r>
+          </a:p>
+        </p:txBody>
+      </p:sp>
+      <p:sp>
+        <p:nvSpPr>
+          <p:cNvPr id="6" name="TextBox 5"/>
+          <p:cNvSpPr txBox="1"/>
+          <p:nvPr/>
+        </p:nvSpPr>
+        <p:spPr>
+          <a:xfrm>
+            <a:off x="640080" y="3840480"/>
+            <a:ext cx="10881360" cy="640080"/>
+          </a:xfrm>
+          <a:prstGeom prst="rect">
+            <a:avLst/>
+          </a:prstGeom>
+          <a:noFill/>
+        </p:spPr>
+        <p:txBody>
+          <a:bodyPr wrap="square" lIns="0" rIns="0" tIns="0" bIns="0" anchor="t">
+            <a:spAutoFit/>
+          </a:bodyPr>
+          <a:lstStyle/>
+          <a:p>
+            <a:pPr algn="ctr"/>
+            <a:r>
+              <a:rPr sz="2000" b="1">
+                <a:solidFill>
+                  <a:srgbClr val="2E8A8A"/>
+                </a:solidFill>
+                <a:latin typeface="Calibri"/>
+              </a:rPr>
+              <a:t>No per-run charge. No per-developer license. No new infrastructure cost.</a:t>
+            </a:r>
+          </a:p>
+        </p:txBody>
+      </p:sp>
+      <p:sp>
+        <p:nvSpPr>
+          <p:cNvPr id="7" name="Rectangle 6"/>
           <p:cNvSpPr/>
           <p:nvPr/>
         </p:nvSpPr>
         <p:spPr>
           <a:xfrm>
-            <a:off x="518007" y="1828800"/>
-            <a:ext cx="3566160" cy="2377440"/>
+            <a:off x="609447" y="4846320"/>
+            <a:ext cx="5394960" cy="640080"/>
           </a:xfrm>
           <a:prstGeom prst="rect">
             <a:avLst/>
           </a:prstGeom>
           <a:solidFill>
-            <a:srgbClr val="FFFFFF"/>
+            <a:srgbClr val="F5F7FA"/>
           </a:solidFill>
           <a:ln w="9525">
             <a:solidFill>
@@ -4651,57 +4721,14 @@
       </p:sp>
       <p:sp>
         <p:nvSpPr>
-          <p:cNvPr id="6" name="Rectangle 5"/>
-          <p:cNvSpPr/>
-          <p:nvPr/>
-        </p:nvSpPr>
-        <p:spPr>
-          <a:xfrm>
-            <a:off x="518007" y="1828800"/>
-            <a:ext cx="3566160" cy="164592"/>
-          </a:xfrm>
-          <a:prstGeom prst="rect">
-            <a:avLst/>
-          </a:prstGeom>
-          <a:solidFill>
-            <a:srgbClr val="1F4E79"/>
-          </a:solidFill>
-          <a:ln>
-            <a:noFill/>
-          </a:ln>
-        </p:spPr>
-        <p:style>
-          <a:lnRef idx="1">
-            <a:schemeClr val="accent1"/>
-          </a:lnRef>
-          <a:fillRef idx="3">
-            <a:schemeClr val="accent1"/>
-          </a:fillRef>
-          <a:effectRef idx="2">
-            <a:schemeClr val="accent1"/>
-          </a:effectRef>
-          <a:fontRef idx="minor">
-            <a:schemeClr val="lt1"/>
-          </a:fontRef>
-        </p:style>
-        <p:txBody>
-          <a:bodyPr rtlCol="0" anchor="ctr" lIns="109728" rIns="109728" tIns="73152" bIns="73152"/>
-          <a:lstStyle/>
-          <a:p>
-            <a:pPr algn="ctr"/>
-          </a:p>
-        </p:txBody>
-      </p:sp>
-      <p:sp>
-        <p:nvSpPr>
-          <p:cNvPr id="7" name="TextBox 6"/>
+          <p:cNvPr id="8" name="TextBox 7"/>
           <p:cNvSpPr txBox="1"/>
           <p:nvPr/>
         </p:nvSpPr>
         <p:spPr>
           <a:xfrm>
-            <a:off x="518007" y="2377440"/>
-            <a:ext cx="3566160" cy="1005840"/>
+            <a:off x="792327" y="4846320"/>
+            <a:ext cx="2377440" cy="640080"/>
           </a:xfrm>
           <a:prstGeom prst="rect">
             <a:avLst/>
@@ -4709,34 +4736,34 @@
           <a:noFill/>
         </p:spPr>
         <p:txBody>
-          <a:bodyPr wrap="square" lIns="0" rIns="0" tIns="0" bIns="0" anchor="t">
+          <a:bodyPr wrap="square" lIns="0" rIns="0" tIns="0" bIns="0" anchor="ctr">
             <a:spAutoFit/>
           </a:bodyPr>
           <a:lstStyle/>
           <a:p>
-            <a:pPr algn="ctr"/>
-            <a:r>
-              <a:rPr sz="4400" b="1">
-                <a:solidFill>
-                  <a:srgbClr val="1F4E79"/>
-                </a:solidFill>
-                <a:latin typeface="Calibri"/>
-              </a:rPr>
-              <a:t>~6 cents</a:t>
-            </a:r>
-          </a:p>
-        </p:txBody>
-      </p:sp>
-      <p:sp>
-        <p:nvSpPr>
-          <p:cNvPr id="8" name="TextBox 7"/>
+            <a:pPr algn="l"/>
+            <a:r>
+              <a:rPr sz="1200" b="0">
+                <a:solidFill>
+                  <a:srgbClr val="6B7785"/>
+                </a:solidFill>
+                <a:latin typeface="Calibri"/>
+              </a:rPr>
+              <a:t>AI / requirement drafting</a:t>
+            </a:r>
+          </a:p>
+        </p:txBody>
+      </p:sp>
+      <p:sp>
+        <p:nvSpPr>
+          <p:cNvPr id="9" name="TextBox 8"/>
           <p:cNvSpPr txBox="1"/>
           <p:nvPr/>
         </p:nvSpPr>
         <p:spPr>
           <a:xfrm>
-            <a:off x="518007" y="3474720"/>
-            <a:ext cx="3566160" cy="548640"/>
+            <a:off x="3215487" y="4846320"/>
+            <a:ext cx="2651760" cy="640080"/>
           </a:xfrm>
           <a:prstGeom prst="rect">
             <a:avLst/>
@@ -4744,40 +4771,40 @@
           <a:noFill/>
         </p:spPr>
         <p:txBody>
-          <a:bodyPr wrap="square" lIns="0" rIns="0" tIns="0" bIns="0" anchor="t">
+          <a:bodyPr wrap="square" lIns="0" rIns="0" tIns="0" bIns="0" anchor="ctr">
             <a:spAutoFit/>
           </a:bodyPr>
           <a:lstStyle/>
           <a:p>
-            <a:pPr algn="ctr"/>
-            <a:r>
-              <a:rPr sz="1500" b="0">
-                <a:solidFill>
-                  <a:srgbClr val="6B7785"/>
-                </a:solidFill>
-                <a:latin typeface="Calibri"/>
-              </a:rPr>
-              <a:t>per daily run</a:t>
-            </a:r>
-          </a:p>
-        </p:txBody>
-      </p:sp>
-      <p:sp>
-        <p:nvSpPr>
-          <p:cNvPr id="9" name="Rectangle 8"/>
+            <a:pPr algn="l"/>
+            <a:r>
+              <a:rPr sz="1300" b="1">
+                <a:solidFill>
+                  <a:srgbClr val="1F4E79"/>
+                </a:solidFill>
+                <a:latin typeface="Calibri"/>
+              </a:rPr>
+              <a:t>Existing Claude subscription</a:t>
+            </a:r>
+          </a:p>
+        </p:txBody>
+      </p:sp>
+      <p:sp>
+        <p:nvSpPr>
+          <p:cNvPr id="10" name="Rectangle 9"/>
           <p:cNvSpPr/>
           <p:nvPr/>
         </p:nvSpPr>
         <p:spPr>
           <a:xfrm>
-            <a:off x="4312767" y="1828800"/>
-            <a:ext cx="3566160" cy="2377440"/>
+            <a:off x="6187287" y="4846320"/>
+            <a:ext cx="5394960" cy="640080"/>
           </a:xfrm>
           <a:prstGeom prst="rect">
             <a:avLst/>
           </a:prstGeom>
           <a:solidFill>
-            <a:srgbClr val="FFFFFF"/>
+            <a:srgbClr val="F5F7FA"/>
           </a:solidFill>
           <a:ln w="9525">
             <a:solidFill>
@@ -4809,57 +4836,14 @@
       </p:sp>
       <p:sp>
         <p:nvSpPr>
-          <p:cNvPr id="10" name="Rectangle 9"/>
-          <p:cNvSpPr/>
-          <p:nvPr/>
-        </p:nvSpPr>
-        <p:spPr>
-          <a:xfrm>
-            <a:off x="4312767" y="1828800"/>
-            <a:ext cx="3566160" cy="164592"/>
-          </a:xfrm>
-          <a:prstGeom prst="rect">
-            <a:avLst/>
-          </a:prstGeom>
-          <a:solidFill>
-            <a:srgbClr val="4A7A4A"/>
-          </a:solidFill>
-          <a:ln>
-            <a:noFill/>
-          </a:ln>
-        </p:spPr>
-        <p:style>
-          <a:lnRef idx="1">
-            <a:schemeClr val="accent1"/>
-          </a:lnRef>
-          <a:fillRef idx="3">
-            <a:schemeClr val="accent1"/>
-          </a:fillRef>
-          <a:effectRef idx="2">
-            <a:schemeClr val="accent1"/>
-          </a:effectRef>
-          <a:fontRef idx="minor">
-            <a:schemeClr val="lt1"/>
-          </a:fontRef>
-        </p:style>
-        <p:txBody>
-          <a:bodyPr rtlCol="0" anchor="ctr" lIns="109728" rIns="109728" tIns="73152" bIns="73152"/>
-          <a:lstStyle/>
-          <a:p>
-            <a:pPr algn="ctr"/>
-          </a:p>
-        </p:txBody>
-      </p:sp>
-      <p:sp>
-        <p:nvSpPr>
           <p:cNvPr id="11" name="TextBox 10"/>
           <p:cNvSpPr txBox="1"/>
           <p:nvPr/>
         </p:nvSpPr>
         <p:spPr>
           <a:xfrm>
-            <a:off x="4312767" y="2377440"/>
-            <a:ext cx="3566160" cy="1005840"/>
+            <a:off x="6370167" y="4846320"/>
+            <a:ext cx="2377440" cy="640080"/>
           </a:xfrm>
           <a:prstGeom prst="rect">
             <a:avLst/>
@@ -4867,20 +4851,20 @@
           <a:noFill/>
         </p:spPr>
         <p:txBody>
-          <a:bodyPr wrap="square" lIns="0" rIns="0" tIns="0" bIns="0" anchor="t">
+          <a:bodyPr wrap="square" lIns="0" rIns="0" tIns="0" bIns="0" anchor="ctr">
             <a:spAutoFit/>
           </a:bodyPr>
           <a:lstStyle/>
           <a:p>
-            <a:pPr algn="ctr"/>
-            <a:r>
-              <a:rPr sz="4400" b="1">
-                <a:solidFill>
-                  <a:srgbClr val="4A7A4A"/>
-                </a:solidFill>
-                <a:latin typeface="Calibri"/>
-              </a:rPr>
-              <a:t>Free</a:t>
+            <a:pPr algn="l"/>
+            <a:r>
+              <a:rPr sz="1200" b="0">
+                <a:solidFill>
+                  <a:srgbClr val="6B7785"/>
+                </a:solidFill>
+                <a:latin typeface="Calibri"/>
+              </a:rPr>
+              <a:t>Audio transcription</a:t>
             </a:r>
           </a:p>
         </p:txBody>
@@ -4893,8 +4877,8 @@
         </p:nvSpPr>
         <p:spPr>
           <a:xfrm>
-            <a:off x="4312767" y="3474720"/>
-            <a:ext cx="3566160" cy="548640"/>
+            <a:off x="8793327" y="4846320"/>
+            <a:ext cx="2651760" cy="640080"/>
           </a:xfrm>
           <a:prstGeom prst="rect">
             <a:avLst/>
@@ -4902,20 +4886,20 @@
           <a:noFill/>
         </p:spPr>
         <p:txBody>
-          <a:bodyPr wrap="square" lIns="0" rIns="0" tIns="0" bIns="0" anchor="t">
+          <a:bodyPr wrap="square" lIns="0" rIns="0" tIns="0" bIns="0" anchor="ctr">
             <a:spAutoFit/>
           </a:bodyPr>
           <a:lstStyle/>
           <a:p>
-            <a:pPr algn="ctr"/>
-            <a:r>
-              <a:rPr sz="1500" b="0">
-                <a:solidFill>
-                  <a:srgbClr val="6B7785"/>
-                </a:solidFill>
-                <a:latin typeface="Calibri"/>
-              </a:rPr>
-              <a:t>audio transcription tier</a:t>
+            <a:pPr algn="l"/>
+            <a:r>
+              <a:rPr sz="1300" b="1">
+                <a:solidFill>
+                  <a:srgbClr val="1F4E79"/>
+                </a:solidFill>
+                <a:latin typeface="Calibri"/>
+              </a:rPr>
+              <a:t>Free tier (Groq)</a:t>
             </a:r>
           </a:p>
         </p:txBody>
@@ -4928,14 +4912,14 @@
         </p:nvSpPr>
         <p:spPr>
           <a:xfrm>
-            <a:off x="8107527" y="1828800"/>
-            <a:ext cx="3566160" cy="2377440"/>
+            <a:off x="609447" y="5577840"/>
+            <a:ext cx="5394960" cy="640080"/>
           </a:xfrm>
           <a:prstGeom prst="rect">
             <a:avLst/>
           </a:prstGeom>
           <a:solidFill>
-            <a:srgbClr val="FFFFFF"/>
+            <a:srgbClr val="F5F7FA"/>
           </a:solidFill>
           <a:ln w="9525">
             <a:solidFill>
@@ -4967,23 +4951,95 @@
       </p:sp>
       <p:sp>
         <p:nvSpPr>
-          <p:cNvPr id="14" name="Rectangle 13"/>
+          <p:cNvPr id="14" name="TextBox 13"/>
+          <p:cNvSpPr txBox="1"/>
+          <p:nvPr/>
+        </p:nvSpPr>
+        <p:spPr>
+          <a:xfrm>
+            <a:off x="792327" y="5577840"/>
+            <a:ext cx="2377440" cy="640080"/>
+          </a:xfrm>
+          <a:prstGeom prst="rect">
+            <a:avLst/>
+          </a:prstGeom>
+          <a:noFill/>
+        </p:spPr>
+        <p:txBody>
+          <a:bodyPr wrap="square" lIns="0" rIns="0" tIns="0" bIns="0" anchor="ctr">
+            <a:spAutoFit/>
+          </a:bodyPr>
+          <a:lstStyle/>
+          <a:p>
+            <a:pPr algn="l"/>
+            <a:r>
+              <a:rPr sz="1200" b="0">
+                <a:solidFill>
+                  <a:srgbClr val="6B7785"/>
+                </a:solidFill>
+                <a:latin typeface="Calibri"/>
+              </a:rPr>
+              <a:t>Central server</a:t>
+            </a:r>
+          </a:p>
+        </p:txBody>
+      </p:sp>
+      <p:sp>
+        <p:nvSpPr>
+          <p:cNvPr id="15" name="TextBox 14"/>
+          <p:cNvSpPr txBox="1"/>
+          <p:nvPr/>
+        </p:nvSpPr>
+        <p:spPr>
+          <a:xfrm>
+            <a:off x="3215487" y="5577840"/>
+            <a:ext cx="2651760" cy="640080"/>
+          </a:xfrm>
+          <a:prstGeom prst="rect">
+            <a:avLst/>
+          </a:prstGeom>
+          <a:noFill/>
+        </p:spPr>
+        <p:txBody>
+          <a:bodyPr wrap="square" lIns="0" rIns="0" tIns="0" bIns="0" anchor="ctr">
+            <a:spAutoFit/>
+          </a:bodyPr>
+          <a:lstStyle/>
+          <a:p>
+            <a:pPr algn="l"/>
+            <a:r>
+              <a:rPr sz="1300" b="1">
+                <a:solidFill>
+                  <a:srgbClr val="1F4E79"/>
+                </a:solidFill>
+                <a:latin typeface="Calibri"/>
+              </a:rPr>
+              <a:t>Shared with OpenProject (no new cost)</a:t>
+            </a:r>
+          </a:p>
+        </p:txBody>
+      </p:sp>
+      <p:sp>
+        <p:nvSpPr>
+          <p:cNvPr id="16" name="Rectangle 15"/>
           <p:cNvSpPr/>
           <p:nvPr/>
         </p:nvSpPr>
         <p:spPr>
           <a:xfrm>
-            <a:off x="8107527" y="1828800"/>
-            <a:ext cx="3566160" cy="164592"/>
+            <a:off x="6187287" y="5577840"/>
+            <a:ext cx="5394960" cy="640080"/>
           </a:xfrm>
           <a:prstGeom prst="rect">
             <a:avLst/>
           </a:prstGeom>
           <a:solidFill>
-            <a:srgbClr val="C9962B"/>
+            <a:srgbClr val="F5F7FA"/>
           </a:solidFill>
-          <a:ln>
-            <a:noFill/>
+          <a:ln w="9525">
+            <a:solidFill>
+              <a:srgbClr val="D5DCE5"/>
+            </a:solidFill>
           </a:ln>
         </p:spPr>
         <p:style>
@@ -5010,14 +5066,14 @@
       </p:sp>
       <p:sp>
         <p:nvSpPr>
-          <p:cNvPr id="15" name="TextBox 14"/>
+          <p:cNvPr id="17" name="TextBox 16"/>
           <p:cNvSpPr txBox="1"/>
           <p:nvPr/>
         </p:nvSpPr>
         <p:spPr>
           <a:xfrm>
-            <a:off x="8107527" y="2377440"/>
-            <a:ext cx="3566160" cy="1005840"/>
+            <a:off x="6370167" y="5577840"/>
+            <a:ext cx="2377440" cy="640080"/>
           </a:xfrm>
           <a:prstGeom prst="rect">
             <a:avLst/>
@@ -5025,34 +5081,34 @@
           <a:noFill/>
         </p:spPr>
         <p:txBody>
-          <a:bodyPr wrap="square" lIns="0" rIns="0" tIns="0" bIns="0" anchor="t">
+          <a:bodyPr wrap="square" lIns="0" rIns="0" tIns="0" bIns="0" anchor="ctr">
             <a:spAutoFit/>
           </a:bodyPr>
           <a:lstStyle/>
           <a:p>
-            <a:pPr algn="ctr"/>
-            <a:r>
-              <a:rPr sz="4400" b="1">
-                <a:solidFill>
-                  <a:srgbClr val="C9962B"/>
-                </a:solidFill>
-                <a:latin typeface="Calibri"/>
-              </a:rPr>
-              <a:t>Zero</a:t>
-            </a:r>
-          </a:p>
-        </p:txBody>
-      </p:sp>
-      <p:sp>
-        <p:nvSpPr>
-          <p:cNvPr id="16" name="TextBox 15"/>
+            <a:pPr algn="l"/>
+            <a:r>
+              <a:rPr sz="1200" b="0">
+                <a:solidFill>
+                  <a:srgbClr val="6B7785"/>
+                </a:solidFill>
+                <a:latin typeface="Calibri"/>
+              </a:rPr>
+              <a:t>GitHub runner + storage</a:t>
+            </a:r>
+          </a:p>
+        </p:txBody>
+      </p:sp>
+      <p:sp>
+        <p:nvSpPr>
+          <p:cNvPr id="18" name="TextBox 17"/>
           <p:cNvSpPr txBox="1"/>
           <p:nvPr/>
         </p:nvSpPr>
         <p:spPr>
           <a:xfrm>
-            <a:off x="8107527" y="3474720"/>
-            <a:ext cx="3566160" cy="548640"/>
+            <a:off x="8793327" y="5577840"/>
+            <a:ext cx="2651760" cy="640080"/>
           </a:xfrm>
           <a:prstGeom prst="rect">
             <a:avLst/>
@@ -5060,71 +5116,20 @@
           <a:noFill/>
         </p:spPr>
         <p:txBody>
-          <a:bodyPr wrap="square" lIns="0" rIns="0" tIns="0" bIns="0" anchor="t">
+          <a:bodyPr wrap="square" lIns="0" rIns="0" tIns="0" bIns="0" anchor="ctr">
             <a:spAutoFit/>
           </a:bodyPr>
           <a:lstStyle/>
           <a:p>
-            <a:pPr algn="ctr"/>
-            <a:r>
-              <a:rPr sz="1500" b="0">
-                <a:solidFill>
-                  <a:srgbClr val="6B7785"/>
-                </a:solidFill>
-                <a:latin typeface="Calibri"/>
-              </a:rPr>
-              <a:t>per-developer license cost</a:t>
-            </a:r>
-          </a:p>
-        </p:txBody>
-      </p:sp>
-      <p:sp>
-        <p:nvSpPr>
-          <p:cNvPr id="17" name="TextBox 16"/>
-          <p:cNvSpPr txBox="1"/>
-          <p:nvPr/>
-        </p:nvSpPr>
-        <p:spPr>
-          <a:xfrm>
-            <a:off x="640080" y="4846320"/>
-            <a:ext cx="10881360" cy="1463040"/>
-          </a:xfrm>
-          <a:prstGeom prst="rect">
-            <a:avLst/>
-          </a:prstGeom>
-          <a:noFill/>
-        </p:spPr>
-        <p:txBody>
-          <a:bodyPr wrap="square" lIns="0" rIns="0" tIns="0" bIns="0" anchor="t">
-            <a:spAutoFit/>
-          </a:bodyPr>
-          <a:lstStyle/>
-          <a:p>
-            <a:pPr algn="ctr"/>
-            <a:r>
-              <a:rPr sz="2000" b="1">
+            <a:pPr algn="l"/>
+            <a:r>
+              <a:rPr sz="1300" b="1">
                 <a:solidFill>
                   <a:srgbClr val="1F4E79"/>
                 </a:solidFill>
                 <a:latin typeface="Calibri"/>
               </a:rPr>
-              <a:t>Scaling is essentially free.</a:t>
-            </a:r>
-          </a:p>
-          <a:p>
-            <a:pPr algn="ctr">
-              <a:spcBef>
-                <a:spcPts val="800"/>
-              </a:spcBef>
-            </a:pPr>
-            <a:r>
-              <a:rPr sz="1400" b="0">
-                <a:solidFill>
-                  <a:srgbClr val="6B7785"/>
-                </a:solidFill>
-                <a:latin typeface="Calibri"/>
-              </a:rPr>
-              <a:t>Adding a second client or a tenth developer changes nothing about how the system runs -- the same daily pass covers everyone.</a:t>
+              <a:t>Self-hosted (no charge)</a:t>
             </a:r>
           </a:p>
         </p:txBody>

</xml_diff>

<commit_message>
system-overview deck: add Questions slide + freshen wording
- Add slide_questions as the deck closer (navy full-bleed, "Questions?"
  in 88pt, "Thank you." subtitle, footer). Deck now 13 slides.
- Tighten three speaker-notes lines that said "today (2026-05-14)" --
  the cutover happened on 2026-05-14 but the deck is presented later;
  shifted to past tense ("on 2026-05-14", "since 2026-05-14") so the
  copy doesn't go stale.
- Drop the legacy "Cost target is around 6 cents per run" line in
  slide_what_ai_does speaker notes -- since the Claude pass runs on
  the Max-tier subscription, marginal per-run cost is $0. Matches the
  cost slide's "$0" hero.

Does not touch the rejected requirement_management generator edits
left in the working tree; those remain unstaged.

Co-Authored-By: Claude Opus 4.7 (1M context) <noreply@anthropic.com>
</commit_message>
<xml_diff>
--- a/docs/NAPCO-Nucleus-System-Overview.pptx
+++ b/docs/NAPCO-Nucleus-System-Overview.pptx
@@ -17,6 +17,7 @@
     <p:sldId id="265" r:id="rId17"/>
     <p:sldId id="266" r:id="rId18"/>
     <p:sldId id="267" r:id="rId19"/>
+    <p:sldId id="268" r:id="rId20"/>
   </p:sldIdLst>
   <p:sldSz cx="12191695" cy="6858000" type="screen4x3"/>
   <p:notesSz cx="6858000" cy="9144000"/>
@@ -513,7 +514,7 @@
           <a:lstStyle/>
           <a:p>
             <a:r>
-              <a:t>Set the frame. Nucleus is the system that takes everything the team says, types, mails or shares with a client over the course of a day and -- with one human review step -- produces a single verification email back to the client confirming what we heard. It runs hands-off; developers do not change their workflow. Today is 2026-05-14, the day the central host moved from the Windows MVPACCESS box to a Linux docker stack on .123. The deck explains the whole pipeline end-to-end.</a:t>
+              <a:t>Set the frame. Nucleus is the system that takes everything the team says, types, mails or shares with a client over the course of a day and -- with one human review step -- produces a single verification email back to the client confirming what we heard. It runs hands-off; developers do not change their workflow. The central host moved from the Windows MVPACCESS box to a Linux docker stack on .123 on 2026-05-14. The deck explains the whole pipeline end-to-end.</a:t>
             </a:r>
           </a:p>
         </p:txBody>
@@ -653,7 +654,7 @@
           <a:lstStyle/>
           <a:p>
             <a:r>
-              <a:t>Status snapshot for today, 2026-05-14. Everything that was supposed to be running on the Linux central host today IS running. The six containers are nucleus-samba, nucleus-transcribe, nucleus-stage-email, nucleus-stage-drive, nucleus-daily-draft, and nucleus-gha-runner. The four channels are calls, chats, email, and Drive. The 23:45 BD fire produced a verification email last night for the one active client. Run `python -m tools.healthcheck` on the host for the live version of this snapshot at any time.</a:t>
+              <a:t>Status snapshot as of 2026-05-14, the cutover day. Everything that was supposed to be running on the Linux central host IS running. The six containers are nucleus-samba, nucleus-transcribe, nucleus-stage-email, nucleus-stage-drive, nucleus-daily-draft, and nucleus-gha-runner. The four channels are calls, chats, email, and Drive. The 23:45 BD fire produced a verification email last night for the one active client. Run `python -m tools.healthcheck` on the host for the live version of this snapshot at any time.</a:t>
             </a:r>
           </a:p>
         </p:txBody>
@@ -748,6 +749,76 @@
 </p:notes>
 </file>
 
+<file path=ppt/notesSlides/notesSlide13.xml><?xml version="1.0" encoding="utf-8"?>
+<p:notes xmlns:a="http://schemas.openxmlformats.org/drawingml/2006/main" xmlns:p="http://schemas.openxmlformats.org/presentationml/2006/main" xmlns:r="http://schemas.openxmlformats.org/officeDocument/2006/relationships">
+  <p:cSld>
+    <p:spTree>
+      <p:nvGrpSpPr>
+        <p:cNvPr id="1" name=""/>
+        <p:cNvGrpSpPr/>
+        <p:nvPr/>
+      </p:nvGrpSpPr>
+      <p:grpSpPr>
+        <a:xfrm>
+          <a:off x="0" y="0"/>
+          <a:ext cx="0" cy="0"/>
+          <a:chOff x="0" y="0"/>
+          <a:chExt cx="0" cy="0"/>
+        </a:xfrm>
+      </p:grpSpPr>
+      <p:sp>
+        <p:nvSpPr>
+          <p:cNvPr id="2" name="Slide Image Placeholder 1"/>
+          <p:cNvSpPr>
+            <a:spLocks noGrp="1"/>
+          </p:cNvSpPr>
+          <p:nvPr>
+            <p:ph type="sldImg" idx="2"/>
+          </p:nvPr>
+        </p:nvSpPr>
+        <p:spPr/>
+      </p:sp>
+      <p:sp>
+        <p:nvSpPr>
+          <p:cNvPr id="3" name="Notes Placeholder 2"/>
+          <p:cNvSpPr>
+            <a:spLocks noGrp="1"/>
+          </p:cNvSpPr>
+          <p:nvPr>
+            <p:ph type="body" idx="3" sz="quarter"/>
+          </p:nvPr>
+        </p:nvSpPr>
+        <p:spPr/>
+        <p:txBody>
+          <a:bodyPr/>
+          <a:lstStyle/>
+          <a:p>
+            <a:r>
+              <a:t>Open the floor. If there's time, offer a live walkthrough -- show the verification email sitting in Gmail Drafts, or run `python -m tools.healthcheck` on the central host to display the live status of all six containers.</a:t>
+            </a:r>
+          </a:p>
+        </p:txBody>
+      </p:sp>
+      <p:sp>
+        <p:nvSpPr>
+          <p:cNvPr id="4" name="Slide Number Placeholder 3"/>
+          <p:cNvSpPr>
+            <a:spLocks noGrp="1"/>
+          </p:cNvSpPr>
+          <p:nvPr>
+            <p:ph type="sldNum" idx="5" sz="quarter"/>
+          </p:nvPr>
+        </p:nvSpPr>
+        <p:spPr/>
+      </p:sp>
+    </p:spTree>
+  </p:cSld>
+  <p:clrMapOvr>
+    <a:masterClrMapping/>
+  </p:clrMapOvr>
+</p:notes>
+</file>
+
 <file path=ppt/notesSlides/notesSlide2.xml><?xml version="1.0" encoding="utf-8"?>
 <p:notes xmlns:a="http://schemas.openxmlformats.org/drawingml/2006/main" xmlns:p="http://schemas.openxmlformats.org/presentationml/2006/main" xmlns:r="http://schemas.openxmlformats.org/officeDocument/2006/relationships">
   <p:cSld>
@@ -1073,7 +1144,7 @@
           <a:lstStyle/>
           <a:p>
             <a:r>
-              <a:t>The central server is the Ubuntu 24.04 box at 172.16.205.123. Implementation detail: it's a single docker-compose stack of six containers -- nucleus-samba (serves the shared folder over SMB on port 445), nucleus-transcribe (the call-to-text loop), nucleus-stage-email (Gmail IMAP every 15 min), nucleus-stage-drive (Google Drive watcher every 15 min), nucleus-daily-draft (the 23:45 BD agent run), and nucleus-gha-runner (self-hosted GitHub Actions runner). The repo is bind-mounted read-only so `git pull` on the host hot-reloads every worker without an image rebuild. State that must survive `compose down` lives in a named docker volume (the sqlite memory database) and on the host filesystem (the shared central tree). Today (2026-05-14) is the day this box took over from the old Windows MVPACCESS agent host.</a:t>
+              <a:t>The central server is the Ubuntu 24.04 box at 172.16.205.123. Implementation detail: it's a single docker-compose stack of six containers -- nucleus-samba (serves the shared folder over SMB on port 445), nucleus-transcribe (the call-to-text loop), nucleus-stage-email (Gmail IMAP every 15 min), nucleus-stage-drive (Google Drive watcher every 15 min), nucleus-daily-draft (the 23:45 BD agent run), and nucleus-gha-runner (self-hosted GitHub Actions runner). The repo is bind-mounted read-only so `git pull` on the host hot-reloads every worker without an image rebuild. State that must survive `compose down` lives in a named docker volume (the sqlite memory database) and on the host filesystem (the shared central tree). This box took over from the old Windows MVPACCESS agent host on 2026-05-14.</a:t>
             </a:r>
           </a:p>
         </p:txBody>
@@ -1143,7 +1214,7 @@
           <a:lstStyle/>
           <a:p>
             <a:r>
-              <a:t>The AI is Anthropic's Claude, running through the Claude Agent SDK in the nucleus-daily-draft container on the central host. It fires once per day at 23:45 BD. The input is a 'Pull Session' document -- about 16,000 characters for a typical day -- that stitches every call transcript, chat window, email thread, and Drive file together, grouped by client and ordered in time. Pre-filters strip system notifications, recorder test snippets, and peer-to-peer dev chatter before Claude sees it. The output is two artefacts per client: a curated Requirements Verification .docx with one entry per requirement (each with a source pointer back to the call timestamp / chat / email) and a .eml draft in Gmail Drafts ready for human review. Cost target is around 6 cents per run thanks to tight scoping and prompt caching.</a:t>
+              <a:t>The AI is Anthropic's Claude, running through the Claude Agent SDK in the nucleus-daily-draft container on the central host. It fires once per day at 23:45 BD. The input is a 'Pull Session' document -- about 16,000 characters for a typical day -- that stitches every call transcript, chat window, email thread, and Drive file together, grouped by client and ordered in time. Pre-filters strip system notifications, recorder test snippets, and peer-to-peer dev chatter before Claude sees it. The output is two artefacts per client: a curated Requirements Verification .docx with one entry per requirement (each with a source pointer back to the call timestamp / chat / email) and a .eml draft in Gmail Drafts ready for human review. Marginal cost per run is $0 -- the Claude pass runs on the team's existing Max-tier subscription rather than per-token API billing.</a:t>
             </a:r>
           </a:p>
         </p:txBody>
@@ -5241,7 +5312,7 @@
                 </a:solidFill>
                 <a:latin typeface="Calibri"/>
               </a:rPr>
-              <a:t>Live as of 2026-05-14.</a:t>
+              <a:t>Live since 2026-05-14.</a:t>
             </a:r>
           </a:p>
         </p:txBody>
@@ -6824,6 +6895,172 @@
                 <a:latin typeface="Calibri"/>
               </a:rPr>
               <a:t>Each next step builds on the same daily pass -- no re-architecture needed.</a:t>
+            </a:r>
+          </a:p>
+        </p:txBody>
+      </p:sp>
+    </p:spTree>
+  </p:cSld>
+  <p:clrMapOvr>
+    <a:masterClrMapping/>
+  </p:clrMapOvr>
+</p:sld>
+</file>
+
+<file path=ppt/slides/slide13.xml><?xml version="1.0" encoding="utf-8"?>
+<p:sld xmlns:a="http://schemas.openxmlformats.org/drawingml/2006/main" xmlns:p="http://schemas.openxmlformats.org/presentationml/2006/main" xmlns:r="http://schemas.openxmlformats.org/officeDocument/2006/relationships">
+  <p:cSld>
+    <p:spTree>
+      <p:nvGrpSpPr>
+        <p:cNvPr id="1" name=""/>
+        <p:cNvGrpSpPr/>
+        <p:nvPr/>
+      </p:nvGrpSpPr>
+      <p:grpSpPr/>
+      <p:sp>
+        <p:nvSpPr>
+          <p:cNvPr id="2" name="Rectangle 1"/>
+          <p:cNvSpPr/>
+          <p:nvPr/>
+        </p:nvSpPr>
+        <p:spPr>
+          <a:xfrm>
+            <a:off x="0" y="0"/>
+            <a:ext cx="12191695" cy="6858000"/>
+          </a:xfrm>
+          <a:prstGeom prst="rect">
+            <a:avLst/>
+          </a:prstGeom>
+          <a:solidFill>
+            <a:srgbClr val="1F4E79"/>
+          </a:solidFill>
+          <a:ln>
+            <a:noFill/>
+          </a:ln>
+        </p:spPr>
+        <p:style>
+          <a:lnRef idx="1">
+            <a:schemeClr val="accent1"/>
+          </a:lnRef>
+          <a:fillRef idx="3">
+            <a:schemeClr val="accent1"/>
+          </a:fillRef>
+          <a:effectRef idx="2">
+            <a:schemeClr val="accent1"/>
+          </a:effectRef>
+          <a:fontRef idx="minor">
+            <a:schemeClr val="lt1"/>
+          </a:fontRef>
+        </p:style>
+        <p:txBody>
+          <a:bodyPr rtlCol="0" anchor="ctr" lIns="109728" rIns="109728" tIns="73152" bIns="73152"/>
+          <a:lstStyle/>
+          <a:p>
+            <a:pPr algn="ctr"/>
+          </a:p>
+        </p:txBody>
+      </p:sp>
+      <p:sp>
+        <p:nvSpPr>
+          <p:cNvPr id="3" name="TextBox 2"/>
+          <p:cNvSpPr txBox="1"/>
+          <p:nvPr/>
+        </p:nvSpPr>
+        <p:spPr>
+          <a:xfrm>
+            <a:off x="822960" y="2377440"/>
+            <a:ext cx="10515600" cy="1828800"/>
+          </a:xfrm>
+          <a:prstGeom prst="rect">
+            <a:avLst/>
+          </a:prstGeom>
+          <a:noFill/>
+        </p:spPr>
+        <p:txBody>
+          <a:bodyPr wrap="square" lIns="0" rIns="0" tIns="0" bIns="0" anchor="ctr">
+            <a:spAutoFit/>
+          </a:bodyPr>
+          <a:lstStyle/>
+          <a:p>
+            <a:pPr algn="ctr"/>
+            <a:r>
+              <a:rPr sz="8800" b="1">
+                <a:solidFill>
+                  <a:srgbClr val="FFFFFF"/>
+                </a:solidFill>
+                <a:latin typeface="Calibri"/>
+              </a:rPr>
+              <a:t>Questions?</a:t>
+            </a:r>
+          </a:p>
+        </p:txBody>
+      </p:sp>
+      <p:sp>
+        <p:nvSpPr>
+          <p:cNvPr id="4" name="TextBox 3"/>
+          <p:cNvSpPr txBox="1"/>
+          <p:nvPr/>
+        </p:nvSpPr>
+        <p:spPr>
+          <a:xfrm>
+            <a:off x="822960" y="4206240"/>
+            <a:ext cx="10515600" cy="731520"/>
+          </a:xfrm>
+          <a:prstGeom prst="rect">
+            <a:avLst/>
+          </a:prstGeom>
+          <a:noFill/>
+        </p:spPr>
+        <p:txBody>
+          <a:bodyPr wrap="square" lIns="0" rIns="0" tIns="0" bIns="0" anchor="ctr">
+            <a:spAutoFit/>
+          </a:bodyPr>
+          <a:lstStyle/>
+          <a:p>
+            <a:pPr algn="ctr"/>
+            <a:r>
+              <a:rPr sz="2400" b="0">
+                <a:solidFill>
+                  <a:srgbClr val="C8D2E0"/>
+                </a:solidFill>
+                <a:latin typeface="Calibri"/>
+              </a:rPr>
+              <a:t>Thank you.</a:t>
+            </a:r>
+          </a:p>
+        </p:txBody>
+      </p:sp>
+      <p:sp>
+        <p:nvSpPr>
+          <p:cNvPr id="5" name="TextBox 4"/>
+          <p:cNvSpPr txBox="1"/>
+          <p:nvPr/>
+        </p:nvSpPr>
+        <p:spPr>
+          <a:xfrm>
+            <a:off x="822960" y="6126480"/>
+            <a:ext cx="10515600" cy="457200"/>
+          </a:xfrm>
+          <a:prstGeom prst="rect">
+            <a:avLst/>
+          </a:prstGeom>
+          <a:noFill/>
+        </p:spPr>
+        <p:txBody>
+          <a:bodyPr wrap="square" lIns="0" rIns="0" tIns="0" bIns="0" anchor="t">
+            <a:spAutoFit/>
+          </a:bodyPr>
+          <a:lstStyle/>
+          <a:p>
+            <a:pPr algn="ctr"/>
+            <a:r>
+              <a:rPr sz="1200" b="0">
+                <a:solidFill>
+                  <a:srgbClr val="9CABBE"/>
+                </a:solidFill>
+                <a:latin typeface="Calibri"/>
+              </a:rPr>
+              <a:t>Adaptive Enterprise / NAPCO labs</a:t>
             </a:r>
           </a:p>
         </p:txBody>

</xml_diff>

<commit_message>
system-overview deck: drop .123 / 172.16.205.123 from speaker notes
The IP and host suffix don't add anything for the non-technical
audience this deck is aimed at. Replaced with "AEL network" /
"the same Linux box" / "the central server" where they appeared.
Slide-visible text was already free of them.

Co-Authored-By: Claude Opus 4.7 (1M context) <noreply@anthropic.com>
</commit_message>
<xml_diff>
--- a/docs/NAPCO-Nucleus-System-Overview.pptx
+++ b/docs/NAPCO-Nucleus-System-Overview.pptx
@@ -514,7 +514,7 @@
           <a:lstStyle/>
           <a:p>
             <a:r>
-              <a:t>Set the frame. Nucleus is the system that takes everything the team says, types, mails or shares with a client over the course of a day and -- with one human review step -- produces a single verification email back to the client confirming what we heard. It runs hands-off; developers do not change their workflow. The central host moved from the Windows MVPACCESS box to a Linux docker stack on .123 on 2026-05-14. The deck explains the whole pipeline end-to-end.</a:t>
+              <a:t>Set the frame. Nucleus is the system that takes everything the team says, types, mails or shares with a client over the course of a day and -- with one human review step -- produces a single verification email back to the client confirming what we heard. It runs hands-off; developers do not change their workflow. The central host moved from a Windows box to a Linux docker stack on 2026-05-14. The deck explains the whole pipeline end-to-end.</a:t>
             </a:r>
           </a:p>
         </p:txBody>
@@ -584,7 +584,7 @@
           <a:lstStyle/>
           <a:p>
             <a:r>
-              <a:t>Cost story for the budget conversation. The incremental cost of running Nucleus per daily pass is effectively zero -- there is no new line item on anyone's bill. The AI side runs against an Anthropic Claude Max-tier subscription, which is a flat monthly subscription we already have in place; it's not metered per token, so the daily verify_session pass doesn't show up as a per-run charge. Audio transcription goes through Groq's free tier -- 8 hours of audio per day, which is well above our actual call volume. The central server is 172.16.205.123, the Linux box that already hosts our OpenProject instance; Nucleus runs as a docker-compose stack alongside it on the same host, so there is no new VM, no new cloud subscription, no new hardware. The GitHub Actions runner that builds and deploys the stack is self-hosted on the same .123 box, so we don't pay GitHub for runner minutes or artifact storage. Heads up on an older number that may surface: a prior version of this deck quoted '~6 cents per run' as the Claude cost. That figure came from a snapshot where Nucleus was billed against the regular Claude API with per-token pricing. Since we moved to Max-tier subscription auth, that per-run charge no longer applies -- the subscription is flat and the marginal cost of one more daily run is $0.</a:t>
+              <a:t>Cost story for the budget conversation. The incremental cost of running Nucleus per daily pass is effectively zero -- there is no new line item on anyone's bill. The AI side runs against an Anthropic Claude Max-tier subscription, which is a flat monthly subscription we already have in place; it's not metered per token, so the daily verify_session pass doesn't show up as a per-run charge. Audio transcription goes through Groq's free tier -- 8 hours of audio per day, which is well above our actual call volume. The central server is the same Linux box that already hosts our OpenProject instance; Nucleus runs as a docker-compose stack alongside it on the same host, so there is no new VM, no new cloud subscription, no new hardware. The GitHub Actions runner that builds and deploys the stack is self-hosted on that same box, so we don't pay GitHub for runner minutes or artifact storage. Heads up on an older number that may surface: a prior version of this deck quoted '~6 cents per run' as the Claude cost. That figure came from a snapshot where Nucleus was billed against the regular Claude API with per-token pricing. Since we moved to Max-tier subscription auth, that per-run charge no longer applies -- the subscription is flat and the marginal cost of one more daily run is $0.</a:t>
             </a:r>
           </a:p>
         </p:txBody>
@@ -1144,7 +1144,7 @@
           <a:lstStyle/>
           <a:p>
             <a:r>
-              <a:t>The central server is the Ubuntu 24.04 box at 172.16.205.123. Implementation detail: it's a single docker-compose stack of six containers -- nucleus-samba (serves the shared folder over SMB on port 445), nucleus-transcribe (the call-to-text loop), nucleus-stage-email (Gmail IMAP every 15 min), nucleus-stage-drive (Google Drive watcher every 15 min), nucleus-daily-draft (the 23:45 BD agent run), and nucleus-gha-runner (self-hosted GitHub Actions runner). The repo is bind-mounted read-only so `git pull` on the host hot-reloads every worker without an image rebuild. State that must survive `compose down` lives in a named docker volume (the sqlite memory database) and on the host filesystem (the shared central tree). This box took over from the old Windows MVPACCESS agent host on 2026-05-14.</a:t>
+              <a:t>The central server is the Ubuntu 24.04 box on the AEL network. Implementation detail: it's a single docker-compose stack of six containers -- nucleus-samba (serves the shared folder over SMB on port 445), nucleus-transcribe (the call-to-text loop), nucleus-stage-email (Gmail IMAP every 15 min), nucleus-stage-drive (Google Drive watcher every 15 min), nucleus-daily-draft (the 23:45 BD agent run), and nucleus-gha-runner (self-hosted GitHub Actions runner). The repo is bind-mounted read-only so `git pull` on the host hot-reloads every worker without an image rebuild. State that must survive `compose down` lives in a named docker volume (the sqlite memory database) and on the host filesystem (the shared central tree). This box took over from the old Windows MVPACCESS agent host on 2026-05-14.</a:t>
             </a:r>
           </a:p>
         </p:txBody>

</xml_diff>